<commit_message>
chore: refine wording from real corporate data to simulated teaching scenario data
</commit_message>
<xml_diff>
--- a/01_每週教學簡報_PPT/ERP_第01週_課程導論、ERP_概念演進與數位轉型.pptx
+++ b/01_每週教學簡報_PPT/ERP_第01週_課程導論、ERP_概念演進與數位轉型.pptx
@@ -15756,7 +15756,7 @@
                 </a:solidFill>
                 <a:latin typeface="微軟正黑體"/>
               </a:rPr>
-              <a:t>在電腦教室中，每位同學都有一台電腦，本課程不搞『只在網頁上隨便點一點』的假模擬</a:t>
+              <a:t>在電腦教室中，每位同學都有一台電腦，本課程帶領大家一人一機動手實作</a:t>
             </a:r>
           </a:p>
           <a:p>
@@ -15784,7 +15784,7 @@
                 </a:solidFill>
                 <a:latin typeface="微軟正黑體"/>
               </a:rPr>
-              <a:t>我們要讓每位同學真正拿到【每週企業實戰專案包 (Starter Code)】：</a:t>
+              <a:t>我們要讓每位同學實際拿到【每週企業實戰專案包 (Starter Code)】：</a:t>
             </a:r>
           </a:p>
           <a:p>
@@ -15812,7 +15812,7 @@
                 </a:solidFill>
                 <a:latin typeface="微軟正黑體"/>
               </a:rPr>
-              <a:t>• 內含真實 ERP 企業營運主檔資料 (`sample_data.json`)</a:t>
+              <a:t>• 內含模擬企業營運與教學情境資料 (`sample_data.json`)</a:t>
             </a:r>
           </a:p>
           <a:p>
@@ -15950,7 +15950,7 @@
                 </a:solidFill>
                 <a:latin typeface="微軟正黑體"/>
               </a:rPr>
-              <a:t>💡 關鍵提點：做中學、學中做，累積真實企業實戰力！</a:t>
+              <a:t>💡 關鍵提點：做中學、學中做，累積扎實實務競爭力！</a:t>
             </a:r>
           </a:p>
         </p:txBody>

</xml_diff>

<commit_message>
feat: rename assessment to 期中考 and 期末考, refine W1 setup pacing, and add W18 GitHub Pages showcase
</commit_message>
<xml_diff>
--- a/01_每週教學簡報_PPT/ERP_第01週_課程導論、ERP_概念演進與數位轉型.pptx
+++ b/01_每週教學簡報_PPT/ERP_第01週_課程導論、ERP_概念演進與數位轉型.pptx
@@ -12137,7 +12137,7 @@
                 </a:solidFill>
                 <a:latin typeface="微軟正黑體"/>
               </a:rPr>
-              <a:t>期中報告繳交：40% (期中實務流程分析報告，線上系統繳交)</a:t>
+              <a:t>期中考：40% (期中實務流程分析與學習評量，線上系統登錄/繳交)</a:t>
             </a:r>
           </a:p>
           <a:p>
@@ -12165,7 +12165,7 @@
                 </a:solidFill>
                 <a:latin typeface="微軟正黑體"/>
               </a:rPr>
-              <a:t>期末專題報告繳交：40% (企業 ERP ✕ AI 專案成果，線上系統繳交)</a:t>
+              <a:t>期末考：40% (期末 ERP ✕ AI 專案成果發表與檢定，線上系統登錄/繳交)</a:t>
             </a:r>
           </a:p>
           <a:p>
@@ -16694,7 +16694,7 @@
                 </a:solidFill>
                 <a:latin typeface="微軟正黑體"/>
               </a:rPr>
-              <a:t>凡取得證照者，於線上報告繳交時勾選證照加分，老師後台即時核發加分！</a:t>
+              <a:t>凡取得證照者，於線上考評成果專區勾選證照加分，老師後台即時核發加分！</a:t>
             </a:r>
           </a:p>
         </p:txBody>
@@ -18234,7 +18234,7 @@
                 </a:solidFill>
                 <a:latin typeface="微軟正黑體"/>
               </a:rPr>
-              <a:t>⚠️【真實課堂慘痛經驗】：</a:t>
+              <a:t>⚠️【課堂實務避坑經驗】：</a:t>
             </a:r>
           </a:p>
           <a:p>
@@ -19464,7 +19464,7 @@
                 </a:solidFill>
                 <a:latin typeface="微軟正黑體"/>
               </a:rPr>
-              <a:t>【目錄巡檢】步驟 28：命令列切換進入第 01 週專案目錄</a:t>
+              <a:t>【環境檢核】步驟 28：確認 Antigravity CLI 認證成功與指令就緒</a:t>
             </a:r>
           </a:p>
         </p:txBody>
@@ -19493,197 +19493,141 @@
           <a:p>
             <a:pPr>
               <a:spcBef>
-                <a:spcPts val="100"/>
-              </a:spcBef>
-              <a:spcAft>
-                <a:spcPts val="800"/>
-              </a:spcAft>
-            </a:pPr>
-            <a:r>
-              <a:rPr sz="2800" b="1">
-                <a:solidFill>
-                  <a:srgbClr val="D97706"/>
-                </a:solidFill>
-                <a:latin typeface="微軟正黑體"/>
-              </a:rPr>
-              <a:t>• </a:t>
-            </a:r>
-            <a:r>
-              <a:rPr sz="2800">
-                <a:solidFill>
-                  <a:srgbClr val="0F172A"/>
-                </a:solidFill>
-                <a:latin typeface="微軟正黑體"/>
-              </a:rPr>
-              <a:t>在 PowerShell 中使用 `cd` 指令切換到實作資料夾：</a:t>
-            </a:r>
-          </a:p>
-          <a:p>
-            <a:pPr>
-              <a:spcBef>
-                <a:spcPts val="100"/>
-              </a:spcBef>
-              <a:spcAft>
-                <a:spcPts val="800"/>
-              </a:spcAft>
-            </a:pPr>
-            <a:r>
-              <a:rPr sz="2800" b="1">
-                <a:solidFill>
-                  <a:srgbClr val="D97706"/>
-                </a:solidFill>
-                <a:latin typeface="微軟正黑體"/>
-              </a:rPr>
-              <a:t>• </a:t>
-            </a:r>
-            <a:r>
-              <a:rPr sz="2800">
-                <a:solidFill>
-                  <a:srgbClr val="0F172A"/>
-                </a:solidFill>
-                <a:latin typeface="微軟正黑體"/>
-              </a:rPr>
-              <a:t>• 輸入：`cd D:/projects/02_每週Antigravity實作專案/01_Week01_企業資料結構與主檔實體建模`</a:t>
-            </a:r>
-          </a:p>
-          <a:p>
-            <a:pPr>
-              <a:spcBef>
-                <a:spcPts val="100"/>
-              </a:spcBef>
-              <a:spcAft>
-                <a:spcPts val="800"/>
-              </a:spcAft>
-            </a:pPr>
-            <a:r>
-              <a:rPr sz="2800" b="1">
-                <a:solidFill>
-                  <a:srgbClr val="D97706"/>
-                </a:solidFill>
-                <a:latin typeface="微軟正黑體"/>
-              </a:rPr>
-              <a:t>• </a:t>
-            </a:r>
-            <a:r>
-              <a:rPr sz="2800">
-                <a:solidFill>
-                  <a:srgbClr val="0F172A"/>
-                </a:solidFill>
-                <a:latin typeface="微軟正黑體"/>
-              </a:rPr>
-              <a:t>輸入指令 `dir` 查看資料夾中四大關鍵檔案：</a:t>
-            </a:r>
-          </a:p>
-          <a:p>
-            <a:pPr>
-              <a:spcBef>
-                <a:spcPts val="100"/>
-              </a:spcBef>
-              <a:spcAft>
-                <a:spcPts val="800"/>
-              </a:spcAft>
-            </a:pPr>
-            <a:r>
-              <a:rPr sz="2800" b="1">
-                <a:solidFill>
-                  <a:srgbClr val="D97706"/>
-                </a:solidFill>
-                <a:latin typeface="微軟正黑體"/>
-              </a:rPr>
-              <a:t>• </a:t>
-            </a:r>
-            <a:r>
-              <a:rPr sz="2800">
-                <a:solidFill>
-                  <a:srgbClr val="0F172A"/>
-                </a:solidFill>
-                <a:latin typeface="微軟正黑體"/>
-              </a:rPr>
-              <a:t>1. `README.md`：本週任務說明書 (AS-IS 痛點與 TO-BE 解法)</a:t>
-            </a:r>
-          </a:p>
-          <a:p>
-            <a:pPr>
-              <a:spcBef>
-                <a:spcPts val="100"/>
-              </a:spcBef>
-              <a:spcAft>
-                <a:spcPts val="800"/>
-              </a:spcAft>
-            </a:pPr>
-            <a:r>
-              <a:rPr sz="2800" b="1">
-                <a:solidFill>
-                  <a:srgbClr val="D97706"/>
-                </a:solidFill>
-                <a:latin typeface="微軟正黑體"/>
-              </a:rPr>
-              <a:t>• </a:t>
-            </a:r>
-            <a:r>
-              <a:rPr sz="2800">
-                <a:solidFill>
-                  <a:srgbClr val="0F172A"/>
-                </a:solidFill>
-                <a:latin typeface="微軟正黑體"/>
-              </a:rPr>
-              <a:t>2. `sample_data.json`：企業原始混亂資料 (內含缺失值與重複項)</a:t>
-            </a:r>
-          </a:p>
-          <a:p>
-            <a:pPr>
-              <a:spcBef>
-                <a:spcPts val="100"/>
-              </a:spcBef>
-              <a:spcAft>
-                <a:spcPts val="800"/>
-              </a:spcAft>
-            </a:pPr>
-            <a:r>
-              <a:rPr sz="2800" b="1">
-                <a:solidFill>
-                  <a:srgbClr val="D97706"/>
-                </a:solidFill>
-                <a:latin typeface="微軟正黑體"/>
-              </a:rPr>
-              <a:t>• </a:t>
-            </a:r>
-            <a:r>
-              <a:rPr sz="2800">
-                <a:solidFill>
-                  <a:srgbClr val="0F172A"/>
-                </a:solidFill>
-                <a:latin typeface="微軟正黑體"/>
-              </a:rPr>
-              <a:t>3. `starter.py`：實務邏輯程式碼 ｜ 4. `verify.py`：評分驗證程式</a:t>
-            </a:r>
-          </a:p>
-          <a:p>
-            <a:pPr>
-              <a:spcBef>
-                <a:spcPts val="100"/>
-              </a:spcBef>
-              <a:spcAft>
-                <a:spcPts val="800"/>
-              </a:spcAft>
-            </a:pPr>
-            <a:r>
-              <a:rPr sz="2800" b="1">
-                <a:solidFill>
-                  <a:srgbClr val="D97706"/>
-                </a:solidFill>
-                <a:latin typeface="微軟正黑體"/>
-              </a:rPr>
-              <a:t>• </a:t>
-            </a:r>
-            <a:r>
-              <a:rPr sz="2800">
-                <a:solidFill>
-                  <a:srgbClr val="0F172A"/>
-                </a:solidFill>
-                <a:latin typeface="微軟正黑體"/>
-              </a:rPr>
-              <a:t>不需要 VS Code！用 Windows 內建記事本 (Notepad) 就能直接檢視修改！</a:t>
+                <a:spcPts val="200"/>
+              </a:spcBef>
+              <a:spcAft>
+                <a:spcPts val="1400"/>
+              </a:spcAft>
+            </a:pPr>
+            <a:r>
+              <a:rPr sz="2800" b="1">
+                <a:solidFill>
+                  <a:srgbClr val="D97706"/>
+                </a:solidFill>
+                <a:latin typeface="微軟正黑體"/>
+              </a:rPr>
+              <a:t>• </a:t>
+            </a:r>
+            <a:r>
+              <a:rPr sz="2800">
+                <a:solidFill>
+                  <a:srgbClr val="0F172A"/>
+                </a:solidFill>
+                <a:latin typeface="微軟正黑體"/>
+              </a:rPr>
+              <a:t>在 PowerShell 中輸入指令檢驗工具狀態：</a:t>
+            </a:r>
+          </a:p>
+          <a:p>
+            <a:pPr>
+              <a:spcBef>
+                <a:spcPts val="200"/>
+              </a:spcBef>
+              <a:spcAft>
+                <a:spcPts val="1400"/>
+              </a:spcAft>
+            </a:pPr>
+            <a:r>
+              <a:rPr sz="2800" b="1">
+                <a:solidFill>
+                  <a:srgbClr val="D97706"/>
+                </a:solidFill>
+                <a:latin typeface="微軟正黑體"/>
+              </a:rPr>
+              <a:t>• </a:t>
+            </a:r>
+            <a:r>
+              <a:rPr sz="2800">
+                <a:solidFill>
+                  <a:srgbClr val="0F172A"/>
+                </a:solidFill>
+                <a:latin typeface="微軟正黑體"/>
+              </a:rPr>
+              <a:t>• 輸入：`python -m antigravity --version` 或查看指令幫助</a:t>
+            </a:r>
+          </a:p>
+          <a:p>
+            <a:pPr>
+              <a:spcBef>
+                <a:spcPts val="200"/>
+              </a:spcBef>
+              <a:spcAft>
+                <a:spcPts val="1400"/>
+              </a:spcAft>
+            </a:pPr>
+            <a:r>
+              <a:rPr sz="2800" b="1">
+                <a:solidFill>
+                  <a:srgbClr val="D97706"/>
+                </a:solidFill>
+                <a:latin typeface="微軟正黑體"/>
+              </a:rPr>
+              <a:t>• </a:t>
+            </a:r>
+            <a:r>
+              <a:rPr sz="2800">
+                <a:solidFill>
+                  <a:srgbClr val="0F172A"/>
+                </a:solidFill>
+                <a:latin typeface="微軟正黑體"/>
+              </a:rPr>
+              <a:t>看到相關版本或說明資訊，代表本機執行環境已完全就緒！</a:t>
+            </a:r>
+          </a:p>
+          <a:p>
+            <a:pPr>
+              <a:spcBef>
+                <a:spcPts val="200"/>
+              </a:spcBef>
+              <a:spcAft>
+                <a:spcPts val="1400"/>
+              </a:spcAft>
+            </a:pPr>
+            <a:r>
+              <a:rPr sz="2800" b="1">
+                <a:solidFill>
+                  <a:srgbClr val="D97706"/>
+                </a:solidFill>
+                <a:latin typeface="微軟正黑體"/>
+              </a:rPr>
+              <a:t>• </a:t>
+            </a:r>
+            <a:r>
+              <a:rPr sz="2800">
+                <a:solidFill>
+                  <a:srgbClr val="0F172A"/>
+                </a:solidFill>
+                <a:latin typeface="微軟正黑體"/>
+              </a:rPr>
+              <a:t>第一週的核心任務在於『打穩環境基礎』，排除一切帳號與認證疑難雜症</a:t>
+            </a:r>
+          </a:p>
+          <a:p>
+            <a:pPr>
+              <a:spcBef>
+                <a:spcPts val="200"/>
+              </a:spcBef>
+              <a:spcAft>
+                <a:spcPts val="1400"/>
+              </a:spcAft>
+            </a:pPr>
+            <a:r>
+              <a:rPr sz="2800" b="1">
+                <a:solidFill>
+                  <a:srgbClr val="D97706"/>
+                </a:solidFill>
+                <a:latin typeface="微軟正黑體"/>
+              </a:rPr>
+              <a:t>• </a:t>
+            </a:r>
+            <a:r>
+              <a:rPr sz="2800">
+                <a:solidFill>
+                  <a:srgbClr val="0F172A"/>
+                </a:solidFill>
+                <a:latin typeface="微軟正黑體"/>
+              </a:rPr>
+              <a:t>同學無需背誦複雜語法，一步步跟著課堂節奏走，就能輕鬆掌握！</a:t>
             </a:r>
           </a:p>
         </p:txBody>
@@ -19737,7 +19681,7 @@
                 </a:solidFill>
                 <a:latin typeface="微軟正黑體"/>
               </a:rPr>
-              <a:t>💡 關鍵提點：Tab 鍵是鍵盤神鍵，輸入開頭兩三個字母按 Tab 即可自動補全路徑！</a:t>
+              <a:t>💡 關鍵提點：環境配置成功就是良好學習的起點！</a:t>
             </a:r>
           </a:p>
         </p:txBody>
@@ -19919,7 +19863,7 @@
                 </a:solidFill>
                 <a:latin typeface="微軟正黑體"/>
               </a:rPr>
-              <a:t>【實務運算】步驟 29：執行 `python starter.py` 產出企業主檔</a:t>
+              <a:t>【下週預告】步驟 29：Antigravity 專案實作預告 (第 02 週正式啟航)</a:t>
             </a:r>
           </a:p>
         </p:txBody>
@@ -19948,169 +19892,141 @@
           <a:p>
             <a:pPr>
               <a:spcBef>
-                <a:spcPts val="100"/>
-              </a:spcBef>
-              <a:spcAft>
-                <a:spcPts val="800"/>
-              </a:spcAft>
-            </a:pPr>
-            <a:r>
-              <a:rPr sz="2800" b="1">
-                <a:solidFill>
-                  <a:srgbClr val="D97706"/>
-                </a:solidFill>
-                <a:latin typeface="微軟正黑體"/>
-              </a:rPr>
-              <a:t>• </a:t>
-            </a:r>
-            <a:r>
-              <a:rPr sz="2800">
-                <a:solidFill>
-                  <a:srgbClr val="0F172A"/>
-                </a:solidFill>
-                <a:latin typeface="微軟正黑體"/>
-              </a:rPr>
-              <a:t>在終端機中輸入指令：</a:t>
-            </a:r>
-          </a:p>
-          <a:p>
-            <a:pPr>
-              <a:spcBef>
-                <a:spcPts val="100"/>
-              </a:spcBef>
-              <a:spcAft>
-                <a:spcPts val="800"/>
-              </a:spcAft>
-            </a:pPr>
-            <a:r>
-              <a:rPr sz="2800" b="1">
-                <a:solidFill>
-                  <a:srgbClr val="D97706"/>
-                </a:solidFill>
-                <a:latin typeface="微軟正黑體"/>
-              </a:rPr>
-              <a:t>• </a:t>
-            </a:r>
-            <a:r>
-              <a:rPr sz="2800">
-                <a:solidFill>
-                  <a:srgbClr val="0F172A"/>
-                </a:solidFill>
-                <a:latin typeface="微軟正黑體"/>
-              </a:rPr>
-              <a:t>• `python starter.py` 並按下 Enter</a:t>
-            </a:r>
-          </a:p>
-          <a:p>
-            <a:pPr>
-              <a:spcBef>
-                <a:spcPts val="100"/>
-              </a:spcBef>
-              <a:spcAft>
-                <a:spcPts val="800"/>
-              </a:spcAft>
-            </a:pPr>
-            <a:r>
-              <a:rPr sz="2800" b="1">
-                <a:solidFill>
-                  <a:srgbClr val="D97706"/>
-                </a:solidFill>
-                <a:latin typeface="微軟正黑體"/>
-              </a:rPr>
-              <a:t>• </a:t>
-            </a:r>
-            <a:r>
-              <a:rPr sz="2800">
-                <a:solidFill>
-                  <a:srgbClr val="0F172A"/>
-                </a:solidFill>
-                <a:latin typeface="微軟正黑體"/>
-              </a:rPr>
-              <a:t>程式會自動讀取 `sample_data.json` 中的混亂主檔資料</a:t>
-            </a:r>
-          </a:p>
-          <a:p>
-            <a:pPr>
-              <a:spcBef>
-                <a:spcPts val="100"/>
-              </a:spcBef>
-              <a:spcAft>
-                <a:spcPts val="800"/>
-              </a:spcAft>
-            </a:pPr>
-            <a:r>
-              <a:rPr sz="2800" b="1">
-                <a:solidFill>
-                  <a:srgbClr val="D97706"/>
-                </a:solidFill>
-                <a:latin typeface="微軟正黑體"/>
-              </a:rPr>
-              <a:t>• </a:t>
-            </a:r>
-            <a:r>
-              <a:rPr sz="2800">
-                <a:solidFill>
-                  <a:srgbClr val="0F172A"/>
-                </a:solidFill>
-                <a:latin typeface="微軟正黑體"/>
-              </a:rPr>
-              <a:t>透過 Antigravity Agentic 邏輯執行：資料格式標準化、去除重複值與防呆防錯</a:t>
-            </a:r>
-          </a:p>
-          <a:p>
-            <a:pPr>
-              <a:spcBef>
-                <a:spcPts val="100"/>
-              </a:spcBef>
-              <a:spcAft>
-                <a:spcPts val="800"/>
-              </a:spcAft>
-            </a:pPr>
-            <a:r>
-              <a:rPr sz="2800" b="1">
-                <a:solidFill>
-                  <a:srgbClr val="D97706"/>
-                </a:solidFill>
-                <a:latin typeface="微軟正黑體"/>
-              </a:rPr>
-              <a:t>• </a:t>
-            </a:r>
-            <a:r>
-              <a:rPr sz="2800">
-                <a:solidFill>
-                  <a:srgbClr val="0F172A"/>
-                </a:solidFill>
-                <a:latin typeface="微軟正黑體"/>
-              </a:rPr>
-              <a:t>終端機印出執行進度，並在當前目錄自動產出成果交付檔案：</a:t>
-            </a:r>
-          </a:p>
-          <a:p>
-            <a:pPr>
-              <a:spcBef>
-                <a:spcPts val="100"/>
-              </a:spcBef>
-              <a:spcAft>
-                <a:spcPts val="800"/>
-              </a:spcAft>
-            </a:pPr>
-            <a:r>
-              <a:rPr sz="2800" b="1">
-                <a:solidFill>
-                  <a:srgbClr val="D97706"/>
-                </a:solidFill>
-                <a:latin typeface="微軟正黑體"/>
-              </a:rPr>
-              <a:t>• </a:t>
-            </a:r>
-            <a:r>
-              <a:rPr sz="2800">
-                <a:solidFill>
-                  <a:srgbClr val="0F172A"/>
-                </a:solidFill>
-                <a:latin typeface="微軟正黑體"/>
-              </a:rPr>
-              <a:t>• `master_data_clean.json` (清洗後之企業乾淨主檔)</a:t>
+                <a:spcPts val="200"/>
+              </a:spcBef>
+              <a:spcAft>
+                <a:spcPts val="1400"/>
+              </a:spcAft>
+            </a:pPr>
+            <a:r>
+              <a:rPr sz="2800" b="1">
+                <a:solidFill>
+                  <a:srgbClr val="D97706"/>
+                </a:solidFill>
+                <a:latin typeface="微軟正黑體"/>
+              </a:rPr>
+              <a:t>• </a:t>
+            </a:r>
+            <a:r>
+              <a:rPr sz="2800">
+                <a:solidFill>
+                  <a:srgbClr val="0F172A"/>
+                </a:solidFill>
+                <a:latin typeface="微軟正黑體"/>
+              </a:rPr>
+              <a:t>⚠️【教學節奏溫馨提醒】：第一週專注於帳號、CLI 認證與雲端備份！</a:t>
+            </a:r>
+          </a:p>
+          <a:p>
+            <a:pPr>
+              <a:spcBef>
+                <a:spcPts val="200"/>
+              </a:spcBef>
+              <a:spcAft>
+                <a:spcPts val="1400"/>
+              </a:spcAft>
+            </a:pPr>
+            <a:r>
+              <a:rPr sz="2800" b="1">
+                <a:solidFill>
+                  <a:srgbClr val="D97706"/>
+                </a:solidFill>
+                <a:latin typeface="微軟正黑體"/>
+              </a:rPr>
+              <a:t>• </a:t>
+            </a:r>
+            <a:r>
+              <a:rPr sz="2800">
+                <a:solidFill>
+                  <a:srgbClr val="0F172A"/>
+                </a:solidFill>
+                <a:latin typeface="微軟正黑體"/>
+              </a:rPr>
+              <a:t>課堂程式碼實作將於【下週第 02 週正式展開】：</a:t>
+            </a:r>
+          </a:p>
+          <a:p>
+            <a:pPr>
+              <a:spcBef>
+                <a:spcPts val="200"/>
+              </a:spcBef>
+              <a:spcAft>
+                <a:spcPts val="1400"/>
+              </a:spcAft>
+            </a:pPr>
+            <a:r>
+              <a:rPr sz="2800" b="1">
+                <a:solidFill>
+                  <a:srgbClr val="D97706"/>
+                </a:solidFill>
+                <a:latin typeface="微軟正黑體"/>
+              </a:rPr>
+              <a:t>• </a:t>
+            </a:r>
+            <a:r>
+              <a:rPr sz="2800">
+                <a:solidFill>
+                  <a:srgbClr val="0F172A"/>
+                </a:solidFill>
+                <a:latin typeface="微軟正黑體"/>
+              </a:rPr>
+              <a:t>• 第 02 週專案主題：企業流程管理 (BPR) ✕ 狀態機流程自動化實作</a:t>
+            </a:r>
+          </a:p>
+          <a:p>
+            <a:pPr>
+              <a:spcBef>
+                <a:spcPts val="200"/>
+              </a:spcBef>
+              <a:spcAft>
+                <a:spcPts val="1400"/>
+              </a:spcAft>
+            </a:pPr>
+            <a:r>
+              <a:rPr sz="2800" b="1">
+                <a:solidFill>
+                  <a:srgbClr val="D97706"/>
+                </a:solidFill>
+                <a:latin typeface="微軟正黑體"/>
+              </a:rPr>
+              <a:t>• </a:t>
+            </a:r>
+            <a:r>
+              <a:rPr sz="2800">
+                <a:solidFill>
+                  <a:srgbClr val="0F172A"/>
+                </a:solidFill>
+                <a:latin typeface="微軟正黑體"/>
+              </a:rPr>
+              <a:t>• 同學將利用今天配置好的本機環境，體驗 AI Agent 自動化流轉單據的威力</a:t>
+            </a:r>
+          </a:p>
+          <a:p>
+            <a:pPr>
+              <a:spcBef>
+                <a:spcPts val="200"/>
+              </a:spcBef>
+              <a:spcAft>
+                <a:spcPts val="1400"/>
+              </a:spcAft>
+            </a:pPr>
+            <a:r>
+              <a:rPr sz="2800" b="1">
+                <a:solidFill>
+                  <a:srgbClr val="D97706"/>
+                </a:solidFill>
+                <a:latin typeface="微軟正黑體"/>
+              </a:rPr>
+              <a:t>• </a:t>
+            </a:r>
+            <a:r>
+              <a:rPr sz="2800">
+                <a:solidFill>
+                  <a:srgbClr val="0F172A"/>
+                </a:solidFill>
+                <a:latin typeface="微軟正黑體"/>
+              </a:rPr>
+              <a:t>第一週不急著跑程式，讓每位同學都有充裕時間確認電腦教室各項工具運作正常！</a:t>
             </a:r>
           </a:p>
         </p:txBody>
@@ -20164,7 +20080,7 @@
                 </a:solidFill>
                 <a:latin typeface="微軟正黑體"/>
               </a:rPr>
-              <a:t>💡 關鍵提點：看見終端機印出清洗成功筆數，代表第一階段運算順利達標！</a:t>
+              <a:t>💡 關鍵提點：按部就班、循序漸進，保證每位同學都能跟上！</a:t>
             </a:r>
           </a:p>
         </p:txBody>
@@ -20346,7 +20262,7 @@
                 </a:solidFill>
                 <a:latin typeface="微軟正黑體"/>
               </a:rPr>
-              <a:t>【自我驗證】步驟 30：執行 `python verify.py` 自我檢查評分</a:t>
+              <a:t>【檔案管理】步驟 30：建立個人專案安全目錄與檔案檢視技巧</a:t>
             </a:r>
           </a:p>
         </p:txBody>
@@ -20375,169 +20291,141 @@
           <a:p>
             <a:pPr>
               <a:spcBef>
-                <a:spcPts val="100"/>
-              </a:spcBef>
-              <a:spcAft>
-                <a:spcPts val="800"/>
-              </a:spcAft>
-            </a:pPr>
-            <a:r>
-              <a:rPr sz="2800" b="1">
-                <a:solidFill>
-                  <a:srgbClr val="D97706"/>
-                </a:solidFill>
-                <a:latin typeface="微軟正黑體"/>
-              </a:rPr>
-              <a:t>• </a:t>
-            </a:r>
-            <a:r>
-              <a:rPr sz="2800">
-                <a:solidFill>
-                  <a:srgbClr val="0F172A"/>
-                </a:solidFill>
-                <a:latin typeface="微軟正黑體"/>
-              </a:rPr>
-              <a:t>每週專案最讚的設計：自帶評分老師 `verify.py`！</a:t>
-            </a:r>
-          </a:p>
-          <a:p>
-            <a:pPr>
-              <a:spcBef>
-                <a:spcPts val="100"/>
-              </a:spcBef>
-              <a:spcAft>
-                <a:spcPts val="800"/>
-              </a:spcAft>
-            </a:pPr>
-            <a:r>
-              <a:rPr sz="2800" b="1">
-                <a:solidFill>
-                  <a:srgbClr val="D97706"/>
-                </a:solidFill>
-                <a:latin typeface="微軟正黑體"/>
-              </a:rPr>
-              <a:t>• </a:t>
-            </a:r>
-            <a:r>
-              <a:rPr sz="2800">
-                <a:solidFill>
-                  <a:srgbClr val="0F172A"/>
-                </a:solidFill>
-                <a:latin typeface="微軟正黑體"/>
-              </a:rPr>
-              <a:t>在終端機中鍵入指令：`python verify.py` 並按下 Enter</a:t>
-            </a:r>
-          </a:p>
-          <a:p>
-            <a:pPr>
-              <a:spcBef>
-                <a:spcPts val="100"/>
-              </a:spcBef>
-              <a:spcAft>
-                <a:spcPts val="800"/>
-              </a:spcAft>
-            </a:pPr>
-            <a:r>
-              <a:rPr sz="2800" b="1">
-                <a:solidFill>
-                  <a:srgbClr val="D97706"/>
-                </a:solidFill>
-                <a:latin typeface="微軟正黑體"/>
-              </a:rPr>
-              <a:t>• </a:t>
-            </a:r>
-            <a:r>
-              <a:rPr sz="2800">
-                <a:solidFill>
-                  <a:srgbClr val="0F172A"/>
-                </a:solidFill>
-                <a:latin typeface="微軟正黑體"/>
-              </a:rPr>
-              <a:t>程式會自動執行 3~5 項企業業務規則檢驗 (如：主檔欄位驗證、除錯率計算)</a:t>
-            </a:r>
-          </a:p>
-          <a:p>
-            <a:pPr>
-              <a:spcBef>
-                <a:spcPts val="100"/>
-              </a:spcBef>
-              <a:spcAft>
-                <a:spcPts val="800"/>
-              </a:spcAft>
-            </a:pPr>
-            <a:r>
-              <a:rPr sz="2800" b="1">
-                <a:solidFill>
-                  <a:srgbClr val="D97706"/>
-                </a:solidFill>
-                <a:latin typeface="微軟正黑體"/>
-              </a:rPr>
-              <a:t>• </a:t>
-            </a:r>
-            <a:r>
-              <a:rPr sz="2800">
-                <a:solidFill>
-                  <a:srgbClr val="0F172A"/>
-                </a:solidFill>
-                <a:latin typeface="微軟正黑體"/>
-              </a:rPr>
-              <a:t>若全部通過，終端機會噴出彩色字樣：</a:t>
-            </a:r>
-          </a:p>
-          <a:p>
-            <a:pPr>
-              <a:spcBef>
-                <a:spcPts val="100"/>
-              </a:spcBef>
-              <a:spcAft>
-                <a:spcPts val="800"/>
-              </a:spcAft>
-            </a:pPr>
-            <a:r>
-              <a:rPr sz="2800" b="1">
-                <a:solidFill>
-                  <a:srgbClr val="D97706"/>
-                </a:solidFill>
-                <a:latin typeface="微軟正黑體"/>
-              </a:rPr>
-              <a:t>• </a:t>
-            </a:r>
-            <a:r>
-              <a:rPr sz="2800">
-                <a:solidFill>
-                  <a:srgbClr val="0F172A"/>
-                </a:solidFill>
-                <a:latin typeface="微軟正黑體"/>
-              </a:rPr>
-              <a:t>✨【SUCCESS】All validation tests passed! 實作成果完全符合企業標準！</a:t>
-            </a:r>
-          </a:p>
-          <a:p>
-            <a:pPr>
-              <a:spcBef>
-                <a:spcPts val="100"/>
-              </a:spcBef>
-              <a:spcAft>
-                <a:spcPts val="800"/>
-              </a:spcAft>
-            </a:pPr>
-            <a:r>
-              <a:rPr sz="2800" b="1">
-                <a:solidFill>
-                  <a:srgbClr val="D97706"/>
-                </a:solidFill>
-                <a:latin typeface="微軟正黑體"/>
-              </a:rPr>
-              <a:t>• </a:t>
-            </a:r>
-            <a:r>
-              <a:rPr sz="2800">
-                <a:solidFill>
-                  <a:srgbClr val="0F172A"/>
-                </a:solidFill>
-                <a:latin typeface="微軟正黑體"/>
-              </a:rPr>
-              <a:t>若有錯誤，會清楚提示是哪一行規則未達標，修改後再測即可！</a:t>
+                <a:spcPts val="200"/>
+              </a:spcBef>
+              <a:spcAft>
+                <a:spcPts val="1400"/>
+              </a:spcAft>
+            </a:pPr>
+            <a:r>
+              <a:rPr sz="2800" b="1">
+                <a:solidFill>
+                  <a:srgbClr val="D97706"/>
+                </a:solidFill>
+                <a:latin typeface="微軟正黑體"/>
+              </a:rPr>
+              <a:t>• </a:t>
+            </a:r>
+            <a:r>
+              <a:rPr sz="2800">
+                <a:solidFill>
+                  <a:srgbClr val="0F172A"/>
+                </a:solidFill>
+                <a:latin typeface="微軟正黑體"/>
+              </a:rPr>
+              <a:t>在 D 槽或個人隨身碟建立乾淨的工作目錄 (例：`D:/erp_projects/`)</a:t>
+            </a:r>
+          </a:p>
+          <a:p>
+            <a:pPr>
+              <a:spcBef>
+                <a:spcPts val="200"/>
+              </a:spcBef>
+              <a:spcAft>
+                <a:spcPts val="1400"/>
+              </a:spcAft>
+            </a:pPr>
+            <a:r>
+              <a:rPr sz="2800" b="1">
+                <a:solidFill>
+                  <a:srgbClr val="D97706"/>
+                </a:solidFill>
+                <a:latin typeface="微軟正黑體"/>
+              </a:rPr>
+              <a:t>• </a:t>
+            </a:r>
+            <a:r>
+              <a:rPr sz="2800">
+                <a:solidFill>
+                  <a:srgbClr val="0F172A"/>
+                </a:solidFill>
+                <a:latin typeface="微軟正黑體"/>
+              </a:rPr>
+              <a:t>⚠️ 目錄命名避坑準則：嚴禁使用中文名稱、空格或特殊字元，確保程式讀寫無誤</a:t>
+            </a:r>
+          </a:p>
+          <a:p>
+            <a:pPr>
+              <a:spcBef>
+                <a:spcPts val="200"/>
+              </a:spcBef>
+              <a:spcAft>
+                <a:spcPts val="1400"/>
+              </a:spcAft>
+            </a:pPr>
+            <a:r>
+              <a:rPr sz="2800" b="1">
+                <a:solidFill>
+                  <a:srgbClr val="D97706"/>
+                </a:solidFill>
+                <a:latin typeface="微軟正黑體"/>
+              </a:rPr>
+              <a:t>• </a:t>
+            </a:r>
+            <a:r>
+              <a:rPr sz="2800">
+                <a:solidFill>
+                  <a:srgbClr val="0F172A"/>
+                </a:solidFill>
+                <a:latin typeface="微軟正黑體"/>
+              </a:rPr>
+              <a:t>免裝 VS Code！點擊檔案右鍵選擇【使用記事本 (Notepad) 開啟】即可輕鬆檢視</a:t>
+            </a:r>
+          </a:p>
+          <a:p>
+            <a:pPr>
+              <a:spcBef>
+                <a:spcPts val="200"/>
+              </a:spcBef>
+              <a:spcAft>
+                <a:spcPts val="1400"/>
+              </a:spcAft>
+            </a:pPr>
+            <a:r>
+              <a:rPr sz="2800" b="1">
+                <a:solidFill>
+                  <a:srgbClr val="D97706"/>
+                </a:solidFill>
+                <a:latin typeface="微軟正黑體"/>
+              </a:rPr>
+              <a:t>• </a:t>
+            </a:r>
+            <a:r>
+              <a:rPr sz="2800">
+                <a:solidFill>
+                  <a:srgbClr val="0F172A"/>
+                </a:solidFill>
+                <a:latin typeface="微軟正黑體"/>
+              </a:rPr>
+              <a:t>平時作業與每週專案包均下載解壓於此專屬目錄中，井然有序不混亂</a:t>
+            </a:r>
+          </a:p>
+          <a:p>
+            <a:pPr>
+              <a:spcBef>
+                <a:spcPts val="200"/>
+              </a:spcBef>
+              <a:spcAft>
+                <a:spcPts val="1400"/>
+              </a:spcAft>
+            </a:pPr>
+            <a:r>
+              <a:rPr sz="2800" b="1">
+                <a:solidFill>
+                  <a:srgbClr val="D97706"/>
+                </a:solidFill>
+                <a:latin typeface="微軟正黑體"/>
+              </a:rPr>
+              <a:t>• </a:t>
+            </a:r>
+            <a:r>
+              <a:rPr sz="2800">
+                <a:solidFill>
+                  <a:srgbClr val="0F172A"/>
+                </a:solidFill>
+                <a:latin typeface="微軟正黑體"/>
+              </a:rPr>
+              <a:t>熟悉檔案與資料夾結構，是成為 ERP 系統分析師的基本功！</a:t>
             </a:r>
           </a:p>
         </p:txBody>
@@ -20591,7 +20479,7 @@
                 </a:solidFill>
                 <a:latin typeface="微軟正黑體"/>
               </a:rPr>
-              <a:t>💡 關鍵提點：寫完馬上知道自己對不對，完全不用擔心做錯！</a:t>
+              <a:t>💡 關鍵提點：路徑簡潔規範，後續實作自然零阻礙！</a:t>
             </a:r>
           </a:p>
         </p:txBody>
@@ -21790,7 +21678,7 @@
                 </a:solidFill>
                 <a:latin typeface="微軟正黑體"/>
               </a:rPr>
-              <a:t>• 途徑 3 (作業繳交)：直接到本課程平台的【📤 學生報告繳交】專區上傳成果檔案！</a:t>
+              <a:t>• 途徑 3 (考評專區)：直接到本課程平台的【📝 學生期中／期末考】專區登錄成果檔案！</a:t>
             </a:r>
           </a:p>
         </p:txBody>
@@ -22425,7 +22313,7 @@
                 </a:solidFill>
                 <a:latin typeface="微軟正黑體"/>
               </a:rPr>
-              <a:t>【作業繳交】步驟 34：成果如何讓老師線上看見？</a:t>
+              <a:t>【考評專區】步驟 34：成果如何讓老師線上看見？</a:t>
             </a:r>
           </a:p>
         </p:txBody>
@@ -22476,7 +22364,7 @@
                 </a:solidFill>
                 <a:latin typeface="微軟正黑體"/>
               </a:rPr>
-              <a:t>本課程提供專屬現代化線上繳交專區，不用再寄隨身碟或 Email 附件！</a:t>
+              <a:t>本課程提供專屬現代化線上專區，不用再寄隨身碟或 Email 附件！</a:t>
             </a:r>
           </a:p>
           <a:p>
@@ -22504,7 +22392,7 @@
                 </a:solidFill>
                 <a:latin typeface="微軟正黑體"/>
               </a:rPr>
-              <a:t>兩種成果繳交方式：</a:t>
+              <a:t>兩種成果登錄方式：</a:t>
             </a:r>
           </a:p>
           <a:p>
@@ -22560,7 +22448,7 @@
                 </a:solidFill>
                 <a:latin typeface="微軟正黑體"/>
               </a:rPr>
-              <a:t>2. 【附件檔案上傳】：上傳您的報告 Word/PDF/Markdown 檔案 (10MB 內)</a:t>
+              <a:t>2. 【附件檔案上傳】：上傳您的成果檔案、簡報或企劃書 (10MB 內)</a:t>
             </a:r>
           </a:p>
           <a:p>
@@ -22588,7 +22476,7 @@
                 </a:solidFill>
                 <a:latin typeface="微軟正黑體"/>
               </a:rPr>
-              <a:t>繳交後即刻存入 Firebase 雲端資料庫，老師將在線上親自評閱打分！</a:t>
+              <a:t>送出後即刻存入 Firebase 雲端資料庫，老師將在線上親自評閱打分！</a:t>
             </a:r>
           </a:p>
         </p:txBody>
@@ -22642,7 +22530,7 @@
                 </a:solidFill>
                 <a:latin typeface="微軟正黑體"/>
               </a:rPr>
-              <a:t>💡 關鍵提點：支援手機、平板或筆電隨時登入查閱自己已繳交的歷程。</a:t>
+              <a:t>💡 關鍵提點：支援手機、平板或筆電隨時登入查閱自己已登錄的歷程。</a:t>
             </a:r>
           </a:p>
         </p:txBody>
@@ -22824,7 +22712,7 @@
                 </a:solidFill>
                 <a:latin typeface="微軟正黑體"/>
               </a:rPr>
-              <a:t>【作業繳交】步驟 35：進入課程平台並使用 Google 登入</a:t>
+              <a:t>【考評專區】步驟 35：進入課程平台並使用 Google 登入</a:t>
             </a:r>
           </a:p>
         </p:txBody>
@@ -23069,7 +22957,7 @@
                 </a:solidFill>
                 <a:latin typeface="微軟正黑體"/>
               </a:rPr>
-              <a:t>💡 關鍵提點：綁定學號與姓名後，所有答題紀錄與報告成果均會歸戶至您的個人成績單！</a:t>
+              <a:t>💡 關鍵提點：綁定學號與姓名後，所有答題紀錄與考評成果均會歸戶至您的個人成績單！</a:t>
             </a:r>
           </a:p>
         </p:txBody>
@@ -23251,7 +23139,7 @@
                 </a:solidFill>
                 <a:latin typeface="微軟正黑體"/>
               </a:rPr>
-              <a:t>【作業繳交】步驟 36：進入學生報告繳交專區</a:t>
+              <a:t>【考評專區】步驟 36：進入學生期中／期末考專區</a:t>
             </a:r>
           </a:p>
         </p:txBody>
@@ -23302,7 +23190,7 @@
                 </a:solidFill>
                 <a:latin typeface="微軟正黑體"/>
               </a:rPr>
-              <a:t>點擊頂部導覽列按鈕【📤 學生報告繳交】進入繳交專區</a:t>
+              <a:t>點擊頂部導覽列按鈕【📝 學生期中／期末考】進入專區</a:t>
             </a:r>
           </a:p>
           <a:p>
@@ -23330,7 +23218,7 @@
                 </a:solidFill>
                 <a:latin typeface="微軟正黑體"/>
               </a:rPr>
-              <a:t>欄位 1【繳交報告類別】：依當前進度挑選『期中報告 (40%)』或『期末報告 (40%)』</a:t>
+              <a:t>欄位 1【繳交考評類別】：依當前進度挑選『期中考 (40%)』或『期末考 (40%)』</a:t>
             </a:r>
           </a:p>
           <a:p>
@@ -23358,7 +23246,7 @@
                 </a:solidFill>
                 <a:latin typeface="微軟正黑體"/>
               </a:rPr>
-              <a:t>欄位 2【專案主題 / 標題】：輸入專案題名 (例：`自行車業主檔實體建模實作報告`)</a:t>
+              <a:t>欄位 2【專案主題 / 標題】：輸入專案題名 (例：`自行車業主檔實體建模實作成果`)</a:t>
             </a:r>
           </a:p>
           <a:p>
@@ -23414,7 +23302,7 @@
                 </a:solidFill>
                 <a:latin typeface="微軟正黑體"/>
               </a:rPr>
-              <a:t>欄位 4【線上成果網址】：貼入您的 GitHub 專案或雲端網址</a:t>
+              <a:t>欄位 4【線上成果網址】：貼入您的 GitHub 專案、GitHub Pages 或雲端網址</a:t>
             </a:r>
           </a:p>
           <a:p>
@@ -23442,7 +23330,7 @@
                 </a:solidFill>
                 <a:latin typeface="微軟正黑體"/>
               </a:rPr>
-              <a:t>欄位 5【附件檔案】：若有 PDF/Word 報告亦可一併附加</a:t>
+              <a:t>欄位 5【附件檔案】：若有 PDF/Word/成果報告亦可一併附加</a:t>
             </a:r>
           </a:p>
         </p:txBody>
@@ -23678,7 +23566,7 @@
                 </a:solidFill>
                 <a:latin typeface="微軟正黑體"/>
               </a:rPr>
-              <a:t>【作業繳交】步驟 37：勾選證照特別加分申請</a:t>
+              <a:t>【考評專區】步驟 37：勾選證照特別加分申請</a:t>
             </a:r>
           </a:p>
         </p:txBody>
@@ -23841,7 +23729,7 @@
                 </a:solidFill>
                 <a:latin typeface="微軟正黑體"/>
               </a:rPr>
-              <a:t>確認資料皆填寫完畢後，點擊最下方綠色按鈕【確認送出繳交報告】！</a:t>
+              <a:t>確認資料皆填寫完畢後，點擊最下方綠色按鈕【確認送出繳交考評成果】！</a:t>
             </a:r>
           </a:p>
         </p:txBody>
@@ -24077,7 +23965,7 @@
                 </a:solidFill>
                 <a:latin typeface="微軟正黑體"/>
               </a:rPr>
-              <a:t>【作業繳交】步驟 38：在右側查看即時反饋與老師評語</a:t>
+              <a:t>【考評專區】步驟 38：在右側查看即時反饋與老師評語</a:t>
             </a:r>
           </a:p>
         </p:txBody>
@@ -24128,7 +24016,7 @@
                 </a:solidFill>
                 <a:latin typeface="微軟正黑體"/>
               </a:rPr>
-              <a:t>送出報告後，右側『我的報告繳交歷程與成績』會立即出現您的報告卡片！</a:t>
+              <a:t>送出成果後，右側『我的期中／期末考繳交歷程與成績』會立即出現您的卡片！</a:t>
             </a:r>
           </a:p>
           <a:p>
@@ -27180,7 +27068,7 @@
                 </a:solidFill>
                 <a:latin typeface="微軟正黑體"/>
               </a:rPr>
-              <a:t>✅ 任務 2：確認已將課程倉庫 Clone 至本機並能以 VS Code 開啟</a:t>
+              <a:t>✅ 任務 2：確認在本機 PowerShell 成功完成 `antigravity login` 授權認證</a:t>
             </a:r>
           </a:p>
           <a:p>
@@ -27208,7 +27096,7 @@
                 </a:solidFill>
                 <a:latin typeface="微軟正黑體"/>
               </a:rPr>
-              <a:t>✅ 任務 3：在終端機成功執行 `python starter.py` 與 `python verify.py`</a:t>
+              <a:t>✅ 任務 3：確認已在 D 槽或隨身碟建立乾淨的工作目錄 (例：`D:/erp_projects/`)</a:t>
             </a:r>
           </a:p>
           <a:p>
@@ -27264,7 +27152,7 @@
                 </a:solidFill>
                 <a:latin typeface="微軟正黑體"/>
               </a:rPr>
-              <a:t>下週預告 (第 02 週)：企業模式與企業流程管理 (BPR) ✕ 狀態機自動化實務！</a:t>
+              <a:t>下週預告 (第 02 週)：企業流程管理 (BPR) ✕ Antigravity 實作專案正式啟航！</a:t>
             </a:r>
           </a:p>
         </p:txBody>

</xml_diff>